<commit_message>
docs: slide 22 (ablation A/B/C) em shapes nativos com mini-pipelines
Refatorado o slide de configuracoes do estudo de ablation
arquitetural de tabela para 3 cartoes nativos lado a lado:

- Cada cartao: badge circular com letra A/B/C no topo, nome do
  config em bold, mini-pipeline horizontal com pilulas + seta,
  descricao do que testa, referencia bibliografica no rodape.
- Config B destacada em NAVY (proposta principal), texto branco,
  demais em branco com borda navy.
- Mini-pipelines mostram o sinal condicionante por config:
    A: [Imagem] -> [ConvNeXt-T]            (sem condicionamento)
    B: [MST 10-dim] -> [FiLM.ConvNeXt-T]   (proposta)
    C: [CLIP-text 512-dim] -> [FiLM.ConvNeXt-T]
- Caption centralizada reafirma 'ceteris paribus'.
- Helpers novos: _mini_pipeline() e _add_arrowhead() reutilizaveis.

29 shapes nativos (13 AUTO_SHAPE + 3 LINE + 13 TEXT_BOX), zero
imagem. Editavel direto no PowerPoint.

Co-Authored-By: Claude Opus 4.7 <noreply@anthropic.com>
</commit_message>
<xml_diff>
--- a/docs/ativo/material_qualificacao_2026-10-05.pptx
+++ b/docs/ativo/material_qualificacao_2026-10-05.pptx
@@ -8336,279 +8336,1051 @@
           </a:p>
         </p:txBody>
       </p:sp>
-      <p:graphicFrame>
-        <p:nvGraphicFramePr>
-          <p:cNvPr id="4" name="Table 3"/>
-          <p:cNvGraphicFramePr>
-            <a:graphicFrameLocks noGrp="1"/>
-          </p:cNvGraphicFramePr>
-          <p:nvPr/>
-        </p:nvGraphicFramePr>
-        <p:xfrm>
-          <a:off x="457200" y="1371600"/>
-          <a:ext cx="11430000" cy="4754880"/>
-        </p:xfrm>
-        <a:graphic>
-          <a:graphicData uri="http://schemas.openxmlformats.org/drawingml/2006/table">
-            <a:tbl>
-              <a:tblPr firstRow="1" bandRow="1">
-                <a:tableStyleId>{5C22544A-7EE6-4342-B048-85BDC9FD1C3A}</a:tableStyleId>
-              </a:tblPr>
-              <a:tblGrid>
-                <a:gridCol w="548640"/>
-                <a:gridCol w="4937760"/>
-                <a:gridCol w="5943600"/>
-              </a:tblGrid>
-              <a:tr h="1188720">
-                <a:tc>
-                  <a:txBody>
-                    <a:bodyPr/>
-                    <a:lstStyle/>
-                    <a:p>
-                      <a:r>
-                        <a:rPr sz="1500" b="1">
-                          <a:solidFill>
-                            <a:srgbClr val="FFFFFF"/>
-                          </a:solidFill>
-                        </a:rPr>
-                        <a:t>ID</a:t>
-                      </a:r>
-                    </a:p>
-                  </a:txBody>
-                  <a:tcPr>
-                    <a:solidFill>
-                      <a:srgbClr val="1F2A4E"/>
-                    </a:solidFill>
-                  </a:tcPr>
-                </a:tc>
-                <a:tc>
-                  <a:txBody>
-                    <a:bodyPr/>
-                    <a:lstStyle/>
-                    <a:p>
-                      <a:r>
-                        <a:rPr sz="1500" b="1">
-                          <a:solidFill>
-                            <a:srgbClr val="FFFFFF"/>
-                          </a:solidFill>
-                        </a:rPr>
-                        <a:t>Configuração</a:t>
-                      </a:r>
-                    </a:p>
-                  </a:txBody>
-                  <a:tcPr>
-                    <a:solidFill>
-                      <a:srgbClr val="1F2A4E"/>
-                    </a:solidFill>
-                  </a:tcPr>
-                </a:tc>
-                <a:tc>
-                  <a:txBody>
-                    <a:bodyPr/>
-                    <a:lstStyle/>
-                    <a:p>
-                      <a:r>
-                        <a:rPr sz="1500" b="1">
-                          <a:solidFill>
-                            <a:srgbClr val="FFFFFF"/>
-                          </a:solidFill>
-                        </a:rPr>
-                        <a:t>O que testa</a:t>
-                      </a:r>
-                    </a:p>
-                  </a:txBody>
-                  <a:tcPr>
-                    <a:solidFill>
-                      <a:srgbClr val="1F2A4E"/>
-                    </a:solidFill>
-                  </a:tcPr>
-                </a:tc>
-              </a:tr>
-              <a:tr h="1188720">
-                <a:tc>
-                  <a:txBody>
-                    <a:bodyPr/>
-                    <a:lstStyle/>
-                    <a:p>
-                      <a:r>
-                        <a:rPr sz="1400">
-                          <a:solidFill>
-                            <a:srgbClr val="3D424E"/>
-                          </a:solidFill>
-                        </a:rPr>
-                        <a:t>A</a:t>
-                      </a:r>
-                    </a:p>
-                  </a:txBody>
-                  <a:tcPr/>
-                </a:tc>
-                <a:tc>
-                  <a:txBody>
-                    <a:bodyPr/>
-                    <a:lstStyle/>
-                    <a:p>
-                      <a:r>
-                        <a:rPr sz="1400">
-                          <a:solidFill>
-                            <a:srgbClr val="3D424E"/>
-                          </a:solidFill>
-                        </a:rPr>
-                        <a:t>ConvNeXt-T puro (baseline)</a:t>
-                      </a:r>
-                    </a:p>
-                  </a:txBody>
-                  <a:tcPr/>
-                </a:tc>
-                <a:tc>
-                  <a:txBody>
-                    <a:bodyPr/>
-                    <a:lstStyle/>
-                    <a:p>
-                      <a:r>
-                        <a:rPr sz="1400">
-                          <a:solidFill>
-                            <a:srgbClr val="3D424E"/>
-                          </a:solidFill>
-                        </a:rPr>
-                        <a:t>Sem condicionamento — controle arquitetural.</a:t>
-                      </a:r>
-                    </a:p>
-                  </a:txBody>
-                  <a:tcPr/>
-                </a:tc>
-              </a:tr>
-              <a:tr h="1188720">
-                <a:tc>
-                  <a:txBody>
-                    <a:bodyPr/>
-                    <a:lstStyle/>
-                    <a:p>
-                      <a:r>
-                        <a:rPr sz="1400">
-                          <a:solidFill>
-                            <a:srgbClr val="3D424E"/>
-                          </a:solidFill>
-                        </a:rPr>
-                        <a:t>B</a:t>
-                      </a:r>
-                    </a:p>
-                  </a:txBody>
-                  <a:tcPr>
-                    <a:solidFill>
-                      <a:srgbClr val="E8EAED"/>
-                    </a:solidFill>
-                  </a:tcPr>
-                </a:tc>
-                <a:tc>
-                  <a:txBody>
-                    <a:bodyPr/>
-                    <a:lstStyle/>
-                    <a:p>
-                      <a:r>
-                        <a:rPr sz="1400">
-                          <a:solidFill>
-                            <a:srgbClr val="3D424E"/>
-                          </a:solidFill>
-                        </a:rPr>
-                        <a:t>ConvNeXt-T + FiLM (sinal MST direto, 10-dim)</a:t>
-                      </a:r>
-                    </a:p>
-                  </a:txBody>
-                  <a:tcPr>
-                    <a:solidFill>
-                      <a:srgbClr val="E8EAED"/>
-                    </a:solidFill>
-                  </a:tcPr>
-                </a:tc>
-                <a:tc>
-                  <a:txBody>
-                    <a:bodyPr/>
-                    <a:lstStyle/>
-                    <a:p>
-                      <a:r>
-                        <a:rPr sz="1400">
-                          <a:solidFill>
-                            <a:srgbClr val="3D424E"/>
-                          </a:solidFill>
-                        </a:rPr>
-                        <a:t>Proposta principal — tom de pele entra como contexto.</a:t>
-                      </a:r>
-                    </a:p>
-                  </a:txBody>
-                  <a:tcPr>
-                    <a:solidFill>
-                      <a:srgbClr val="E8EAED"/>
-                    </a:solidFill>
-                  </a:tcPr>
-                </a:tc>
-              </a:tr>
-              <a:tr h="1188720">
-                <a:tc>
-                  <a:txBody>
-                    <a:bodyPr/>
-                    <a:lstStyle/>
-                    <a:p>
-                      <a:r>
-                        <a:rPr sz="1400">
-                          <a:solidFill>
-                            <a:srgbClr val="3D424E"/>
-                          </a:solidFill>
-                        </a:rPr>
-                        <a:t>C</a:t>
-                      </a:r>
-                    </a:p>
-                  </a:txBody>
-                  <a:tcPr/>
-                </a:tc>
-                <a:tc>
-                  <a:txBody>
-                    <a:bodyPr/>
-                    <a:lstStyle/>
-                    <a:p>
-                      <a:r>
-                        <a:rPr sz="1400">
-                          <a:solidFill>
-                            <a:srgbClr val="3D424E"/>
-                          </a:solidFill>
-                        </a:rPr>
-                        <a:t>ConvNeXt-T + FiLM (sinal via CLIP-text, 512-dim)</a:t>
-                      </a:r>
-                    </a:p>
-                  </a:txBody>
-                  <a:tcPr/>
-                </a:tc>
-                <a:tc>
-                  <a:txBody>
-                    <a:bodyPr/>
-                    <a:lstStyle/>
-                    <a:p>
-                      <a:r>
-                        <a:rPr sz="1400">
-                          <a:solidFill>
-                            <a:srgbClr val="3D424E"/>
-                          </a:solidFill>
-                        </a:rPr>
-                        <a:t>Alternativa moderna — Radford et al. (2021) + Dehdashtian et al. (2024).</a:t>
-                      </a:r>
-                    </a:p>
-                  </a:txBody>
-                  <a:tcPr/>
-                </a:tc>
-              </a:tr>
-            </a:tbl>
-          </a:graphicData>
-        </a:graphic>
-      </p:graphicFrame>
-      <p:sp>
-        <p:nvSpPr>
-          <p:cNvPr id="5" name="TextBox 4"/>
+      <p:sp>
+        <p:nvSpPr>
+          <p:cNvPr id="4" name="Rounded Rectangle 3"/>
+          <p:cNvSpPr/>
+          <p:nvPr/>
+        </p:nvSpPr>
+        <p:spPr>
+          <a:xfrm>
+            <a:off x="333756" y="1325880"/>
+            <a:ext cx="3657600" cy="4617720"/>
+          </a:xfrm>
+          <a:prstGeom prst="roundRect">
+            <a:avLst/>
+          </a:prstGeom>
+          <a:solidFill>
+            <a:srgbClr val="FFFFFF"/>
+          </a:solidFill>
+          <a:ln w="16510">
+            <a:solidFill>
+              <a:srgbClr val="1F2A4E"/>
+            </a:solidFill>
+          </a:ln>
+        </p:spPr>
+        <p:style>
+          <a:lnRef idx="1">
+            <a:schemeClr val="accent1"/>
+          </a:lnRef>
+          <a:fillRef idx="3">
+            <a:schemeClr val="accent1"/>
+          </a:fillRef>
+          <a:effectRef idx="2">
+            <a:schemeClr val="accent1"/>
+          </a:effectRef>
+          <a:fontRef idx="minor">
+            <a:schemeClr val="lt1"/>
+          </a:fontRef>
+        </p:style>
+        <p:txBody>
+          <a:bodyPr rtlCol="0" anchor="ctr" tIns="0"/>
+          <a:lstStyle/>
+          <a:p>
+            <a:pPr algn="ctr"/>
+          </a:p>
+        </p:txBody>
+      </p:sp>
+      <p:sp>
+        <p:nvSpPr>
+          <p:cNvPr id="5" name="Oval 4"/>
+          <p:cNvSpPr/>
+          <p:nvPr/>
+        </p:nvSpPr>
+        <p:spPr>
+          <a:xfrm>
+            <a:off x="1819656" y="1554480"/>
+            <a:ext cx="685800" cy="685800"/>
+          </a:xfrm>
+          <a:prstGeom prst="ellipse">
+            <a:avLst/>
+          </a:prstGeom>
+          <a:solidFill>
+            <a:srgbClr val="1F2A4E"/>
+          </a:solidFill>
+          <a:ln w="19050">
+            <a:solidFill>
+              <a:srgbClr val="1F2A4E"/>
+            </a:solidFill>
+          </a:ln>
+        </p:spPr>
+        <p:style>
+          <a:lnRef idx="1">
+            <a:schemeClr val="accent1"/>
+          </a:lnRef>
+          <a:fillRef idx="3">
+            <a:schemeClr val="accent1"/>
+          </a:fillRef>
+          <a:effectRef idx="2">
+            <a:schemeClr val="accent1"/>
+          </a:effectRef>
+          <a:fontRef idx="minor">
+            <a:schemeClr val="lt1"/>
+          </a:fontRef>
+        </p:style>
+        <p:txBody>
+          <a:bodyPr rtlCol="0" anchor="ctr" tIns="0" bIns="0"/>
+          <a:lstStyle/>
+          <a:p>
+            <a:pPr algn="ctr"/>
+            <a:r>
+              <a:rPr sz="2800" b="1">
+                <a:solidFill>
+                  <a:srgbClr val="FFFFFF"/>
+                </a:solidFill>
+              </a:rPr>
+              <a:t>A</a:t>
+            </a:r>
+          </a:p>
+        </p:txBody>
+      </p:sp>
+      <p:sp>
+        <p:nvSpPr>
+          <p:cNvPr id="6" name="TextBox 5"/>
           <p:cNvSpPr txBox="1"/>
           <p:nvPr/>
         </p:nvSpPr>
         <p:spPr>
           <a:xfrm>
-            <a:off x="457200" y="6446520"/>
-            <a:ext cx="10515600" cy="365760"/>
+            <a:off x="470916" y="2331720"/>
+            <a:ext cx="3383280" cy="868680"/>
+          </a:xfrm>
+          <a:prstGeom prst="rect">
+            <a:avLst/>
+          </a:prstGeom>
+          <a:noFill/>
+        </p:spPr>
+        <p:txBody>
+          <a:bodyPr wrap="square">
+            <a:spAutoFit/>
+          </a:bodyPr>
+          <a:lstStyle/>
+          <a:p>
+            <a:pPr algn="ctr"/>
+            <a:r>
+              <a:rPr sz="1600" b="1">
+                <a:solidFill>
+                  <a:srgbClr val="1F2A4E"/>
+                </a:solidFill>
+              </a:rPr>
+              <a:t>ConvNeXt-T puro</a:t>
+            </a:r>
+          </a:p>
+        </p:txBody>
+      </p:sp>
+      <p:sp>
+        <p:nvSpPr>
+          <p:cNvPr id="7" name="Rounded Rectangle 6"/>
+          <p:cNvSpPr/>
+          <p:nvPr/>
+        </p:nvSpPr>
+        <p:spPr>
+          <a:xfrm>
+            <a:off x="516636" y="3291839"/>
+            <a:ext cx="1152144" cy="502920"/>
+          </a:xfrm>
+          <a:prstGeom prst="roundRect">
+            <a:avLst/>
+          </a:prstGeom>
+          <a:solidFill>
+            <a:srgbClr val="E8EAED"/>
+          </a:solidFill>
+          <a:ln w="13970">
+            <a:solidFill>
+              <a:srgbClr val="3D424E"/>
+            </a:solidFill>
+          </a:ln>
+        </p:spPr>
+        <p:style>
+          <a:lnRef idx="1">
+            <a:schemeClr val="accent1"/>
+          </a:lnRef>
+          <a:fillRef idx="3">
+            <a:schemeClr val="accent1"/>
+          </a:fillRef>
+          <a:effectRef idx="2">
+            <a:schemeClr val="accent1"/>
+          </a:effectRef>
+          <a:fontRef idx="minor">
+            <a:schemeClr val="lt1"/>
+          </a:fontRef>
+        </p:style>
+        <p:txBody>
+          <a:bodyPr rtlCol="0" anchor="ctr" lIns="36576" rIns="36576" tIns="18288" bIns="18288"/>
+          <a:lstStyle/>
+          <a:p>
+            <a:pPr algn="ctr"/>
+            <a:r>
+              <a:rPr sz="1000" b="1">
+                <a:solidFill>
+                  <a:srgbClr val="3D424E"/>
+                </a:solidFill>
+              </a:rPr>
+              <a:t>Imagem</a:t>
+            </a:r>
+          </a:p>
+        </p:txBody>
+      </p:sp>
+      <p:sp>
+        <p:nvSpPr>
+          <p:cNvPr id="8" name="Rounded Rectangle 7"/>
+          <p:cNvSpPr/>
+          <p:nvPr/>
+        </p:nvSpPr>
+        <p:spPr>
+          <a:xfrm>
+            <a:off x="2327148" y="3291839"/>
+            <a:ext cx="1481328" cy="502920"/>
+          </a:xfrm>
+          <a:prstGeom prst="roundRect">
+            <a:avLst/>
+          </a:prstGeom>
+          <a:solidFill>
+            <a:srgbClr val="FFFFFF"/>
+          </a:solidFill>
+          <a:ln w="13970">
+            <a:solidFill>
+              <a:srgbClr val="1F2A4E"/>
+            </a:solidFill>
+          </a:ln>
+        </p:spPr>
+        <p:style>
+          <a:lnRef idx="1">
+            <a:schemeClr val="accent1"/>
+          </a:lnRef>
+          <a:fillRef idx="3">
+            <a:schemeClr val="accent1"/>
+          </a:fillRef>
+          <a:effectRef idx="2">
+            <a:schemeClr val="accent1"/>
+          </a:effectRef>
+          <a:fontRef idx="minor">
+            <a:schemeClr val="lt1"/>
+          </a:fontRef>
+        </p:style>
+        <p:txBody>
+          <a:bodyPr rtlCol="0" anchor="ctr" lIns="36576" rIns="36576" tIns="18288" bIns="18288"/>
+          <a:lstStyle/>
+          <a:p>
+            <a:pPr algn="ctr"/>
+            <a:r>
+              <a:rPr sz="1000" b="1">
+                <a:solidFill>
+                  <a:srgbClr val="1F2A4E"/>
+                </a:solidFill>
+              </a:rPr>
+              <a:t>ConvNeXt-T</a:t>
+            </a:r>
+          </a:p>
+        </p:txBody>
+      </p:sp>
+      <p:cxnSp>
+        <p:nvCxnSpPr>
+          <p:cNvPr id="9" name="Connector 8"/>
+          <p:cNvCxnSpPr/>
+          <p:nvPr/>
+        </p:nvCxnSpPr>
+        <p:spPr>
+          <a:xfrm>
+            <a:off x="1668780" y="3543299"/>
+            <a:ext cx="658368" cy="0"/>
+          </a:xfrm>
+          <a:prstGeom prst="bentConnector3">
+            <a:avLst/>
+          </a:prstGeom>
+          <a:ln w="25400">
+            <a:solidFill>
+              <a:srgbClr val="3D424E"/>
+            </a:solidFill>
+            <a:tailEnd type="triangle" w="med" len="med"/>
+          </a:ln>
+        </p:spPr>
+        <p:style>
+          <a:lnRef idx="2">
+            <a:schemeClr val="accent1"/>
+          </a:lnRef>
+          <a:fillRef idx="0">
+            <a:schemeClr val="accent1"/>
+          </a:fillRef>
+          <a:effectRef idx="1">
+            <a:schemeClr val="accent1"/>
+          </a:effectRef>
+          <a:fontRef idx="minor">
+            <a:schemeClr val="tx1"/>
+          </a:fontRef>
+        </p:style>
+      </p:cxnSp>
+      <p:sp>
+        <p:nvSpPr>
+          <p:cNvPr id="10" name="TextBox 9"/>
+          <p:cNvSpPr txBox="1"/>
+          <p:nvPr/>
+        </p:nvSpPr>
+        <p:spPr>
+          <a:xfrm>
+            <a:off x="516636" y="4069080"/>
+            <a:ext cx="3291840" cy="960120"/>
+          </a:xfrm>
+          <a:prstGeom prst="rect">
+            <a:avLst/>
+          </a:prstGeom>
+          <a:noFill/>
+        </p:spPr>
+        <p:txBody>
+          <a:bodyPr wrap="square">
+            <a:spAutoFit/>
+          </a:bodyPr>
+          <a:lstStyle/>
+          <a:p>
+            <a:pPr algn="ctr"/>
+            <a:r>
+              <a:rPr sz="1300">
+                <a:solidFill>
+                  <a:srgbClr val="3D424E"/>
+                </a:solidFill>
+              </a:rPr>
+              <a:t>Controle arquitetural
+sem condicionamento.</a:t>
+            </a:r>
+          </a:p>
+        </p:txBody>
+      </p:sp>
+      <p:sp>
+        <p:nvSpPr>
+          <p:cNvPr id="11" name="TextBox 10"/>
+          <p:cNvSpPr txBox="1"/>
+          <p:nvPr/>
+        </p:nvSpPr>
+        <p:spPr>
+          <a:xfrm>
+            <a:off x="516636" y="5166360"/>
+            <a:ext cx="3291840" cy="640080"/>
+          </a:xfrm>
+          <a:prstGeom prst="rect">
+            <a:avLst/>
+          </a:prstGeom>
+          <a:noFill/>
+        </p:spPr>
+        <p:txBody>
+          <a:bodyPr wrap="square">
+            <a:spAutoFit/>
+          </a:bodyPr>
+          <a:lstStyle/>
+          <a:p>
+            <a:pPr algn="ctr"/>
+            <a:r>
+              <a:rPr sz="1050" i="1">
+                <a:solidFill>
+                  <a:srgbClr val="707682"/>
+                </a:solidFill>
+              </a:rPr>
+              <a:t>Baseline</a:t>
+            </a:r>
+          </a:p>
+        </p:txBody>
+      </p:sp>
+      <p:sp>
+        <p:nvSpPr>
+          <p:cNvPr id="12" name="Rounded Rectangle 11"/>
+          <p:cNvSpPr/>
+          <p:nvPr/>
+        </p:nvSpPr>
+        <p:spPr>
+          <a:xfrm>
+            <a:off x="4265676" y="1325880"/>
+            <a:ext cx="3657600" cy="4617720"/>
+          </a:xfrm>
+          <a:prstGeom prst="roundRect">
+            <a:avLst/>
+          </a:prstGeom>
+          <a:solidFill>
+            <a:srgbClr val="1F2A4E"/>
+          </a:solidFill>
+          <a:ln w="30480">
+            <a:solidFill>
+              <a:srgbClr val="1F2A4E"/>
+            </a:solidFill>
+          </a:ln>
+        </p:spPr>
+        <p:style>
+          <a:lnRef idx="1">
+            <a:schemeClr val="accent1"/>
+          </a:lnRef>
+          <a:fillRef idx="3">
+            <a:schemeClr val="accent1"/>
+          </a:fillRef>
+          <a:effectRef idx="2">
+            <a:schemeClr val="accent1"/>
+          </a:effectRef>
+          <a:fontRef idx="minor">
+            <a:schemeClr val="lt1"/>
+          </a:fontRef>
+        </p:style>
+        <p:txBody>
+          <a:bodyPr rtlCol="0" anchor="ctr" tIns="0"/>
+          <a:lstStyle/>
+          <a:p>
+            <a:pPr algn="ctr"/>
+          </a:p>
+        </p:txBody>
+      </p:sp>
+      <p:sp>
+        <p:nvSpPr>
+          <p:cNvPr id="13" name="Oval 12"/>
+          <p:cNvSpPr/>
+          <p:nvPr/>
+        </p:nvSpPr>
+        <p:spPr>
+          <a:xfrm>
+            <a:off x="5751576" y="1554480"/>
+            <a:ext cx="685800" cy="685800"/>
+          </a:xfrm>
+          <a:prstGeom prst="ellipse">
+            <a:avLst/>
+          </a:prstGeom>
+          <a:solidFill>
+            <a:srgbClr val="FFFFFF"/>
+          </a:solidFill>
+          <a:ln w="19050">
+            <a:solidFill>
+              <a:srgbClr val="1F2A4E"/>
+            </a:solidFill>
+          </a:ln>
+        </p:spPr>
+        <p:style>
+          <a:lnRef idx="1">
+            <a:schemeClr val="accent1"/>
+          </a:lnRef>
+          <a:fillRef idx="3">
+            <a:schemeClr val="accent1"/>
+          </a:fillRef>
+          <a:effectRef idx="2">
+            <a:schemeClr val="accent1"/>
+          </a:effectRef>
+          <a:fontRef idx="minor">
+            <a:schemeClr val="lt1"/>
+          </a:fontRef>
+        </p:style>
+        <p:txBody>
+          <a:bodyPr rtlCol="0" anchor="ctr" tIns="0" bIns="0"/>
+          <a:lstStyle/>
+          <a:p>
+            <a:pPr algn="ctr"/>
+            <a:r>
+              <a:rPr sz="2800" b="1">
+                <a:solidFill>
+                  <a:srgbClr val="1F2A4E"/>
+                </a:solidFill>
+              </a:rPr>
+              <a:t>B</a:t>
+            </a:r>
+          </a:p>
+        </p:txBody>
+      </p:sp>
+      <p:sp>
+        <p:nvSpPr>
+          <p:cNvPr id="14" name="TextBox 13"/>
+          <p:cNvSpPr txBox="1"/>
+          <p:nvPr/>
+        </p:nvSpPr>
+        <p:spPr>
+          <a:xfrm>
+            <a:off x="4402836" y="2331720"/>
+            <a:ext cx="3383280" cy="868680"/>
+          </a:xfrm>
+          <a:prstGeom prst="rect">
+            <a:avLst/>
+          </a:prstGeom>
+          <a:noFill/>
+        </p:spPr>
+        <p:txBody>
+          <a:bodyPr wrap="square">
+            <a:spAutoFit/>
+          </a:bodyPr>
+          <a:lstStyle/>
+          <a:p>
+            <a:pPr algn="ctr"/>
+            <a:r>
+              <a:rPr sz="1600" b="1">
+                <a:solidFill>
+                  <a:srgbClr val="FFFFFF"/>
+                </a:solidFill>
+              </a:rPr>
+              <a:t>ConvNeXt-T + FiLM
+(MST direto, 10-dim)</a:t>
+            </a:r>
+          </a:p>
+        </p:txBody>
+      </p:sp>
+      <p:sp>
+        <p:nvSpPr>
+          <p:cNvPr id="15" name="Rounded Rectangle 14"/>
+          <p:cNvSpPr/>
+          <p:nvPr/>
+        </p:nvSpPr>
+        <p:spPr>
+          <a:xfrm>
+            <a:off x="4448556" y="3291839"/>
+            <a:ext cx="1382572" cy="502920"/>
+          </a:xfrm>
+          <a:prstGeom prst="roundRect">
+            <a:avLst/>
+          </a:prstGeom>
+          <a:solidFill>
+            <a:srgbClr val="3D68BB"/>
+          </a:solidFill>
+          <a:ln w="13970">
+            <a:solidFill>
+              <a:srgbClr val="1F2A4E"/>
+            </a:solidFill>
+          </a:ln>
+        </p:spPr>
+        <p:style>
+          <a:lnRef idx="1">
+            <a:schemeClr val="accent1"/>
+          </a:lnRef>
+          <a:fillRef idx="3">
+            <a:schemeClr val="accent1"/>
+          </a:fillRef>
+          <a:effectRef idx="2">
+            <a:schemeClr val="accent1"/>
+          </a:effectRef>
+          <a:fontRef idx="minor">
+            <a:schemeClr val="lt1"/>
+          </a:fontRef>
+        </p:style>
+        <p:txBody>
+          <a:bodyPr rtlCol="0" anchor="ctr" lIns="36576" rIns="36576" tIns="18288" bIns="18288"/>
+          <a:lstStyle/>
+          <a:p>
+            <a:pPr algn="ctr"/>
+            <a:r>
+              <a:rPr sz="1000" b="1">
+                <a:solidFill>
+                  <a:srgbClr val="FFFFFF"/>
+                </a:solidFill>
+              </a:rPr>
+              <a:t>MST (10-dim)</a:t>
+            </a:r>
+          </a:p>
+        </p:txBody>
+      </p:sp>
+      <p:sp>
+        <p:nvSpPr>
+          <p:cNvPr id="16" name="Rounded Rectangle 15"/>
+          <p:cNvSpPr/>
+          <p:nvPr/>
+        </p:nvSpPr>
+        <p:spPr>
+          <a:xfrm>
+            <a:off x="6489496" y="3291839"/>
+            <a:ext cx="1250899" cy="502920"/>
+          </a:xfrm>
+          <a:prstGeom prst="roundRect">
+            <a:avLst/>
+          </a:prstGeom>
+          <a:solidFill>
+            <a:srgbClr val="B4C4E8"/>
+          </a:solidFill>
+          <a:ln w="13970">
+            <a:solidFill>
+              <a:srgbClr val="1F2A4E"/>
+            </a:solidFill>
+          </a:ln>
+        </p:spPr>
+        <p:style>
+          <a:lnRef idx="1">
+            <a:schemeClr val="accent1"/>
+          </a:lnRef>
+          <a:fillRef idx="3">
+            <a:schemeClr val="accent1"/>
+          </a:fillRef>
+          <a:effectRef idx="2">
+            <a:schemeClr val="accent1"/>
+          </a:effectRef>
+          <a:fontRef idx="minor">
+            <a:schemeClr val="lt1"/>
+          </a:fontRef>
+        </p:style>
+        <p:txBody>
+          <a:bodyPr rtlCol="0" anchor="ctr" lIns="36576" rIns="36576" tIns="18288" bIns="18288"/>
+          <a:lstStyle/>
+          <a:p>
+            <a:pPr algn="ctr"/>
+            <a:r>
+              <a:rPr sz="1000" b="1">
+                <a:solidFill>
+                  <a:srgbClr val="1F2A4E"/>
+                </a:solidFill>
+              </a:rPr>
+              <a:t>FiLM · ConvNeXt-T</a:t>
+            </a:r>
+          </a:p>
+        </p:txBody>
+      </p:sp>
+      <p:cxnSp>
+        <p:nvCxnSpPr>
+          <p:cNvPr id="17" name="Connector 16"/>
+          <p:cNvCxnSpPr/>
+          <p:nvPr/>
+        </p:nvCxnSpPr>
+        <p:spPr>
+          <a:xfrm>
+            <a:off x="5831128" y="3543299"/>
+            <a:ext cx="658368" cy="0"/>
+          </a:xfrm>
+          <a:prstGeom prst="bentConnector3">
+            <a:avLst/>
+          </a:prstGeom>
+          <a:ln w="25400">
+            <a:solidFill>
+              <a:srgbClr val="FFFFFF"/>
+            </a:solidFill>
+            <a:tailEnd type="triangle" w="med" len="med"/>
+          </a:ln>
+        </p:spPr>
+        <p:style>
+          <a:lnRef idx="2">
+            <a:schemeClr val="accent1"/>
+          </a:lnRef>
+          <a:fillRef idx="0">
+            <a:schemeClr val="accent1"/>
+          </a:fillRef>
+          <a:effectRef idx="1">
+            <a:schemeClr val="accent1"/>
+          </a:effectRef>
+          <a:fontRef idx="minor">
+            <a:schemeClr val="tx1"/>
+          </a:fontRef>
+        </p:style>
+      </p:cxnSp>
+      <p:sp>
+        <p:nvSpPr>
+          <p:cNvPr id="18" name="TextBox 17"/>
+          <p:cNvSpPr txBox="1"/>
+          <p:nvPr/>
+        </p:nvSpPr>
+        <p:spPr>
+          <a:xfrm>
+            <a:off x="4448556" y="4069080"/>
+            <a:ext cx="3291840" cy="960120"/>
+          </a:xfrm>
+          <a:prstGeom prst="rect">
+            <a:avLst/>
+          </a:prstGeom>
+          <a:noFill/>
+        </p:spPr>
+        <p:txBody>
+          <a:bodyPr wrap="square">
+            <a:spAutoFit/>
+          </a:bodyPr>
+          <a:lstStyle/>
+          <a:p>
+            <a:pPr algn="ctr"/>
+            <a:r>
+              <a:rPr sz="1300">
+                <a:solidFill>
+                  <a:srgbClr val="B4C4E8"/>
+                </a:solidFill>
+              </a:rPr>
+              <a:t>Proposta principal — tom
+de pele contínuo como
+contexto arquitetural.</a:t>
+            </a:r>
+          </a:p>
+        </p:txBody>
+      </p:sp>
+      <p:sp>
+        <p:nvSpPr>
+          <p:cNvPr id="19" name="TextBox 18"/>
+          <p:cNvSpPr txBox="1"/>
+          <p:nvPr/>
+        </p:nvSpPr>
+        <p:spPr>
+          <a:xfrm>
+            <a:off x="4448556" y="5166360"/>
+            <a:ext cx="3291840" cy="640080"/>
+          </a:xfrm>
+          <a:prstGeom prst="rect">
+            <a:avLst/>
+          </a:prstGeom>
+          <a:noFill/>
+        </p:spPr>
+        <p:txBody>
+          <a:bodyPr wrap="square">
+            <a:spAutoFit/>
+          </a:bodyPr>
+          <a:lstStyle/>
+          <a:p>
+            <a:pPr algn="ctr"/>
+            <a:r>
+              <a:rPr sz="1050" i="1">
+                <a:solidFill>
+                  <a:srgbClr val="B4C4E8"/>
+                </a:solidFill>
+              </a:rPr>
+              <a:t>Perez et al. (2018) + Monk
+(Schumann et al., 2023)</a:t>
+            </a:r>
+          </a:p>
+        </p:txBody>
+      </p:sp>
+      <p:sp>
+        <p:nvSpPr>
+          <p:cNvPr id="20" name="Rounded Rectangle 19"/>
+          <p:cNvSpPr/>
+          <p:nvPr/>
+        </p:nvSpPr>
+        <p:spPr>
+          <a:xfrm>
+            <a:off x="8197596" y="1325880"/>
+            <a:ext cx="3657600" cy="4617720"/>
+          </a:xfrm>
+          <a:prstGeom prst="roundRect">
+            <a:avLst/>
+          </a:prstGeom>
+          <a:solidFill>
+            <a:srgbClr val="FFFFFF"/>
+          </a:solidFill>
+          <a:ln w="16510">
+            <a:solidFill>
+              <a:srgbClr val="1F2A4E"/>
+            </a:solidFill>
+          </a:ln>
+        </p:spPr>
+        <p:style>
+          <a:lnRef idx="1">
+            <a:schemeClr val="accent1"/>
+          </a:lnRef>
+          <a:fillRef idx="3">
+            <a:schemeClr val="accent1"/>
+          </a:fillRef>
+          <a:effectRef idx="2">
+            <a:schemeClr val="accent1"/>
+          </a:effectRef>
+          <a:fontRef idx="minor">
+            <a:schemeClr val="lt1"/>
+          </a:fontRef>
+        </p:style>
+        <p:txBody>
+          <a:bodyPr rtlCol="0" anchor="ctr" tIns="0"/>
+          <a:lstStyle/>
+          <a:p>
+            <a:pPr algn="ctr"/>
+          </a:p>
+        </p:txBody>
+      </p:sp>
+      <p:sp>
+        <p:nvSpPr>
+          <p:cNvPr id="21" name="Oval 20"/>
+          <p:cNvSpPr/>
+          <p:nvPr/>
+        </p:nvSpPr>
+        <p:spPr>
+          <a:xfrm>
+            <a:off x="9683496" y="1554480"/>
+            <a:ext cx="685800" cy="685800"/>
+          </a:xfrm>
+          <a:prstGeom prst="ellipse">
+            <a:avLst/>
+          </a:prstGeom>
+          <a:solidFill>
+            <a:srgbClr val="1F2A4E"/>
+          </a:solidFill>
+          <a:ln w="19050">
+            <a:solidFill>
+              <a:srgbClr val="1F2A4E"/>
+            </a:solidFill>
+          </a:ln>
+        </p:spPr>
+        <p:style>
+          <a:lnRef idx="1">
+            <a:schemeClr val="accent1"/>
+          </a:lnRef>
+          <a:fillRef idx="3">
+            <a:schemeClr val="accent1"/>
+          </a:fillRef>
+          <a:effectRef idx="2">
+            <a:schemeClr val="accent1"/>
+          </a:effectRef>
+          <a:fontRef idx="minor">
+            <a:schemeClr val="lt1"/>
+          </a:fontRef>
+        </p:style>
+        <p:txBody>
+          <a:bodyPr rtlCol="0" anchor="ctr" tIns="0" bIns="0"/>
+          <a:lstStyle/>
+          <a:p>
+            <a:pPr algn="ctr"/>
+            <a:r>
+              <a:rPr sz="2800" b="1">
+                <a:solidFill>
+                  <a:srgbClr val="FFFFFF"/>
+                </a:solidFill>
+              </a:rPr>
+              <a:t>C</a:t>
+            </a:r>
+          </a:p>
+        </p:txBody>
+      </p:sp>
+      <p:sp>
+        <p:nvSpPr>
+          <p:cNvPr id="22" name="TextBox 21"/>
+          <p:cNvSpPr txBox="1"/>
+          <p:nvPr/>
+        </p:nvSpPr>
+        <p:spPr>
+          <a:xfrm>
+            <a:off x="8334756" y="2331720"/>
+            <a:ext cx="3383280" cy="868680"/>
+          </a:xfrm>
+          <a:prstGeom prst="rect">
+            <a:avLst/>
+          </a:prstGeom>
+          <a:noFill/>
+        </p:spPr>
+        <p:txBody>
+          <a:bodyPr wrap="square">
+            <a:spAutoFit/>
+          </a:bodyPr>
+          <a:lstStyle/>
+          <a:p>
+            <a:pPr algn="ctr"/>
+            <a:r>
+              <a:rPr sz="1600" b="1">
+                <a:solidFill>
+                  <a:srgbClr val="1F2A4E"/>
+                </a:solidFill>
+              </a:rPr>
+              <a:t>ConvNeXt-T + FiLM
+(CLIP-text, 512-dim)</a:t>
+            </a:r>
+          </a:p>
+        </p:txBody>
+      </p:sp>
+      <p:sp>
+        <p:nvSpPr>
+          <p:cNvPr id="23" name="Rounded Rectangle 22"/>
+          <p:cNvSpPr/>
+          <p:nvPr/>
+        </p:nvSpPr>
+        <p:spPr>
+          <a:xfrm>
+            <a:off x="8380475" y="3291839"/>
+            <a:ext cx="1382572" cy="502920"/>
+          </a:xfrm>
+          <a:prstGeom prst="roundRect">
+            <a:avLst/>
+          </a:prstGeom>
+          <a:solidFill>
+            <a:srgbClr val="E8EAED"/>
+          </a:solidFill>
+          <a:ln w="13970">
+            <a:solidFill>
+              <a:srgbClr val="1F2A4E"/>
+            </a:solidFill>
+          </a:ln>
+        </p:spPr>
+        <p:style>
+          <a:lnRef idx="1">
+            <a:schemeClr val="accent1"/>
+          </a:lnRef>
+          <a:fillRef idx="3">
+            <a:schemeClr val="accent1"/>
+          </a:fillRef>
+          <a:effectRef idx="2">
+            <a:schemeClr val="accent1"/>
+          </a:effectRef>
+          <a:fontRef idx="minor">
+            <a:schemeClr val="lt1"/>
+          </a:fontRef>
+        </p:style>
+        <p:txBody>
+          <a:bodyPr rtlCol="0" anchor="ctr" lIns="36576" rIns="36576" tIns="18288" bIns="18288"/>
+          <a:lstStyle/>
+          <a:p>
+            <a:pPr algn="ctr"/>
+            <a:r>
+              <a:rPr sz="1000" b="1">
+                <a:solidFill>
+                  <a:srgbClr val="1F2A4E"/>
+                </a:solidFill>
+              </a:rPr>
+              <a:t>CLIP-text (512-dim)</a:t>
+            </a:r>
+          </a:p>
+        </p:txBody>
+      </p:sp>
+      <p:sp>
+        <p:nvSpPr>
+          <p:cNvPr id="24" name="Rounded Rectangle 23"/>
+          <p:cNvSpPr/>
+          <p:nvPr/>
+        </p:nvSpPr>
+        <p:spPr>
+          <a:xfrm>
+            <a:off x="10421416" y="3291839"/>
+            <a:ext cx="1250899" cy="502920"/>
+          </a:xfrm>
+          <a:prstGeom prst="roundRect">
+            <a:avLst/>
+          </a:prstGeom>
+          <a:solidFill>
+            <a:srgbClr val="FFFFFF"/>
+          </a:solidFill>
+          <a:ln w="13970">
+            <a:solidFill>
+              <a:srgbClr val="1F2A4E"/>
+            </a:solidFill>
+          </a:ln>
+        </p:spPr>
+        <p:style>
+          <a:lnRef idx="1">
+            <a:schemeClr val="accent1"/>
+          </a:lnRef>
+          <a:fillRef idx="3">
+            <a:schemeClr val="accent1"/>
+          </a:fillRef>
+          <a:effectRef idx="2">
+            <a:schemeClr val="accent1"/>
+          </a:effectRef>
+          <a:fontRef idx="minor">
+            <a:schemeClr val="lt1"/>
+          </a:fontRef>
+        </p:style>
+        <p:txBody>
+          <a:bodyPr rtlCol="0" anchor="ctr" lIns="36576" rIns="36576" tIns="18288" bIns="18288"/>
+          <a:lstStyle/>
+          <a:p>
+            <a:pPr algn="ctr"/>
+            <a:r>
+              <a:rPr sz="1000" b="1">
+                <a:solidFill>
+                  <a:srgbClr val="1F2A4E"/>
+                </a:solidFill>
+              </a:rPr>
+              <a:t>FiLM · ConvNeXt-T</a:t>
+            </a:r>
+          </a:p>
+        </p:txBody>
+      </p:sp>
+      <p:cxnSp>
+        <p:nvCxnSpPr>
+          <p:cNvPr id="25" name="Connector 24"/>
+          <p:cNvCxnSpPr/>
+          <p:nvPr/>
+        </p:nvCxnSpPr>
+        <p:spPr>
+          <a:xfrm>
+            <a:off x="9763048" y="3543299"/>
+            <a:ext cx="658368" cy="0"/>
+          </a:xfrm>
+          <a:prstGeom prst="bentConnector3">
+            <a:avLst/>
+          </a:prstGeom>
+          <a:ln w="25400">
+            <a:solidFill>
+              <a:srgbClr val="3D68BB"/>
+            </a:solidFill>
+            <a:tailEnd type="triangle" w="med" len="med"/>
+          </a:ln>
+        </p:spPr>
+        <p:style>
+          <a:lnRef idx="2">
+            <a:schemeClr val="accent1"/>
+          </a:lnRef>
+          <a:fillRef idx="0">
+            <a:schemeClr val="accent1"/>
+          </a:fillRef>
+          <a:effectRef idx="1">
+            <a:schemeClr val="accent1"/>
+          </a:effectRef>
+          <a:fontRef idx="minor">
+            <a:schemeClr val="tx1"/>
+          </a:fontRef>
+        </p:style>
+      </p:cxnSp>
+      <p:sp>
+        <p:nvSpPr>
+          <p:cNvPr id="26" name="TextBox 25"/>
+          <p:cNvSpPr txBox="1"/>
+          <p:nvPr/>
+        </p:nvSpPr>
+        <p:spPr>
+          <a:xfrm>
+            <a:off x="8380475" y="4069080"/>
+            <a:ext cx="3291840" cy="960120"/>
+          </a:xfrm>
+          <a:prstGeom prst="rect">
+            <a:avLst/>
+          </a:prstGeom>
+          <a:noFill/>
+        </p:spPr>
+        <p:txBody>
+          <a:bodyPr wrap="square">
+            <a:spAutoFit/>
+          </a:bodyPr>
+          <a:lstStyle/>
+          <a:p>
+            <a:pPr algn="ctr"/>
+            <a:r>
+              <a:rPr sz="1300">
+                <a:solidFill>
+                  <a:srgbClr val="3D424E"/>
+                </a:solidFill>
+              </a:rPr>
+              <a:t>Alternativa moderna —
+embedding textual rico
+como sinal condicionante.</a:t>
+            </a:r>
+          </a:p>
+        </p:txBody>
+      </p:sp>
+      <p:sp>
+        <p:nvSpPr>
+          <p:cNvPr id="27" name="TextBox 26"/>
+          <p:cNvSpPr txBox="1"/>
+          <p:nvPr/>
+        </p:nvSpPr>
+        <p:spPr>
+          <a:xfrm>
+            <a:off x="8380475" y="5166360"/>
+            <a:ext cx="3291840" cy="640080"/>
+          </a:xfrm>
+          <a:prstGeom prst="rect">
+            <a:avLst/>
+          </a:prstGeom>
+          <a:noFill/>
+        </p:spPr>
+        <p:txBody>
+          <a:bodyPr wrap="square">
+            <a:spAutoFit/>
+          </a:bodyPr>
+          <a:lstStyle/>
+          <a:p>
+            <a:pPr algn="ctr"/>
+            <a:r>
+              <a:rPr sz="1050" i="1">
+                <a:solidFill>
+                  <a:srgbClr val="707682"/>
+                </a:solidFill>
+              </a:rPr>
+              <a:t>Radford et al. (2021) +
+Dehdashtian et al. (2024)</a:t>
+            </a:r>
+          </a:p>
+        </p:txBody>
+      </p:sp>
+      <p:sp>
+        <p:nvSpPr>
+          <p:cNvPr id="28" name="TextBox 27"/>
+          <p:cNvSpPr txBox="1"/>
+          <p:nvPr/>
+        </p:nvSpPr>
+        <p:spPr>
+          <a:xfrm>
+            <a:off x="457200" y="6035040"/>
+            <a:ext cx="11247120" cy="365760"/>
           </a:xfrm>
           <a:prstGeom prst="rect">
             <a:avLst/>
@@ -8621,6 +9393,41 @@
           </a:bodyPr>
           <a:lstStyle/>
           <a:p>
+            <a:pPr algn="ctr">
+              <a:defRPr sz="1200" i="1">
+                <a:solidFill>
+                  <a:srgbClr val="707682"/>
+                </a:solidFill>
+              </a:defRPr>
+            </a:pPr>
+            <a:r>
+              <a:t>Ceteris paribus: mesmo backbone (ConvNeXt-T), mesmo dataset (FairFace), mesmas três sementes, mesma receita de treino — varia-se apenas o sinal condicionante.</a:t>
+            </a:r>
+          </a:p>
+        </p:txBody>
+      </p:sp>
+      <p:sp>
+        <p:nvSpPr>
+          <p:cNvPr id="29" name="TextBox 28"/>
+          <p:cNvSpPr txBox="1"/>
+          <p:nvPr/>
+        </p:nvSpPr>
+        <p:spPr>
+          <a:xfrm>
+            <a:off x="457200" y="6446520"/>
+            <a:ext cx="10515600" cy="365760"/>
+          </a:xfrm>
+          <a:prstGeom prst="rect">
+            <a:avLst/>
+          </a:prstGeom>
+          <a:noFill/>
+        </p:spPr>
+        <p:txBody>
+          <a:bodyPr wrap="none">
+            <a:spAutoFit/>
+          </a:bodyPr>
+          <a:lstStyle/>
+          <a:p>
             <a:pPr>
               <a:defRPr sz="900" i="1">
                 <a:solidFill>
@@ -8636,7 +9443,7 @@
       </p:sp>
       <p:sp>
         <p:nvSpPr>
-          <p:cNvPr id="6" name="TextBox 5"/>
+          <p:cNvPr id="30" name="TextBox 29"/>
           <p:cNvSpPr txBox="1"/>
           <p:nvPr/>
         </p:nvSpPr>

</xml_diff>